<commit_message>
chore: snapshot current project state
</commit_message>
<xml_diff>
--- a/ppt-output/runs/20260411-010156-midterm-report/presentation-final.pptx
+++ b/ppt-output/runs/20260411-010156-midterm-report/presentation-final.pptx
@@ -118,12 +118,12 @@
   <p:extLst>
     <p:ext uri="{EFAFB233-063F-42B5-8137-9DF3F51BA10A}">
       <p15:sldGuideLst xmlns:p15="http://schemas.microsoft.com/office/powerpoint/2012/main">
-        <p15:guide id="1" orient="horz" pos="2236" userDrawn="1">
+        <p15:guide id="1" orient="horz" pos="2238" userDrawn="1">
           <p15:clr>
             <a:srgbClr val="A4A3A4"/>
           </p15:clr>
         </p15:guide>
-        <p15:guide id="2" pos="2857" userDrawn="1">
+        <p15:guide id="2" pos="2862" userDrawn="1">
           <p15:clr>
             <a:srgbClr val="A4A3A4"/>
           </p15:clr>
@@ -4400,546 +4400,6 @@
       </p:sp>
       <p:sp>
         <p:nvSpPr>
-          <p:cNvPr id="637" name="T637"/>
-          <p:cNvSpPr txBox="1"/>
-          <p:nvPr/>
-        </p:nvSpPr>
-        <p:spPr>
-          <a:xfrm>
-            <a:off x="6172200" y="5328642"/>
-            <a:ext cx="1066800" cy="228600"/>
-          </a:xfrm>
-          <a:prstGeom prst="rect">
-            <a:avLst/>
-          </a:prstGeom>
-          <a:noFill/>
-          <a:ln>
-            <a:noFill/>
-          </a:ln>
-        </p:spPr>
-        <p:txBody>
-          <a:bodyPr wrap="none" lIns="0" tIns="0" rIns="0" bIns="0" anchor="b"/>
-          <a:lstStyle/>
-          <a:p>
-            <a:pPr>
-              <a:lnSpc>
-                <a:spcPct val="90000"/>
-              </a:lnSpc>
-              <a:spcBef>
-                <a:spcPts val="0"/>
-              </a:spcBef>
-              <a:spcAft>
-                <a:spcPts val="0"/>
-              </a:spcAft>
-            </a:pPr>
-            <a:r>
-              <a:rPr lang="zh-CN" sz="1200" b="1" dirty="0">
-                <a:solidFill>
-                  <a:srgbClr val="212529"/>
-                </a:solidFill>
-                <a:latin typeface="Noto Sans SC"/>
-                <a:ea typeface="Noto Sans SC"/>
-              </a:rPr>
-              <a:t>已生成公式简析</a:t>
-            </a:r>
-            <a:endParaRPr lang="zh-CN" sz="1200" b="1" dirty="0">
-              <a:solidFill>
-                <a:srgbClr val="212529"/>
-              </a:solidFill>
-              <a:latin typeface="Noto Sans SC"/>
-              <a:ea typeface="Noto Sans SC"/>
-            </a:endParaRPr>
-          </a:p>
-        </p:txBody>
-      </p:sp>
-      <p:sp>
-        <p:nvSpPr>
-          <p:cNvPr id="638" name="T638"/>
-          <p:cNvSpPr txBox="1"/>
-          <p:nvPr/>
-        </p:nvSpPr>
-        <p:spPr>
-          <a:xfrm>
-            <a:off x="6172200" y="5585817"/>
-            <a:ext cx="4453681" cy="228600"/>
-          </a:xfrm>
-          <a:prstGeom prst="rect">
-            <a:avLst/>
-          </a:prstGeom>
-          <a:noFill/>
-          <a:ln>
-            <a:noFill/>
-          </a:ln>
-        </p:spPr>
-        <p:txBody>
-          <a:bodyPr wrap="none" lIns="0" tIns="0" rIns="0" bIns="0" anchor="b"/>
-          <a:lstStyle/>
-          <a:p>
-            <a:pPr>
-              <a:lnSpc>
-                <a:spcPct val="90000"/>
-              </a:lnSpc>
-              <a:spcBef>
-                <a:spcPts val="0"/>
-              </a:spcBef>
-              <a:spcAft>
-                <a:spcPts val="0"/>
-              </a:spcAft>
-            </a:pPr>
-            <a:r>
-              <a:rPr lang="zh-CN" sz="1200" dirty="0">
-                <a:solidFill>
-                  <a:srgbClr val="6B7280"/>
-                </a:solidFill>
-                <a:latin typeface="Noto Sans SC"/>
-                <a:ea typeface="Noto Sans SC"/>
-              </a:rPr>
-              <a:t>当前长式公式已生成，但单行过长，不适合直接贴图。负荷子式以</a:t>
-            </a:r>
-            <a:endParaRPr lang="zh-CN" sz="1200" dirty="0">
-              <a:solidFill>
-                <a:srgbClr val="6B7280"/>
-              </a:solidFill>
-              <a:latin typeface="Noto Sans SC"/>
-              <a:ea typeface="Noto Sans SC"/>
-            </a:endParaRPr>
-          </a:p>
-        </p:txBody>
-      </p:sp>
-      <p:sp>
-        <p:nvSpPr>
-          <p:cNvPr id="639" name="T639"/>
-          <p:cNvSpPr txBox="1"/>
-          <p:nvPr/>
-        </p:nvSpPr>
-        <p:spPr>
-          <a:xfrm>
-            <a:off x="10625881" y="5585817"/>
-            <a:ext cx="845343" cy="228600"/>
-          </a:xfrm>
-          <a:prstGeom prst="rect">
-            <a:avLst/>
-          </a:prstGeom>
-          <a:noFill/>
-          <a:ln>
-            <a:noFill/>
-          </a:ln>
-        </p:spPr>
-        <p:txBody>
-          <a:bodyPr wrap="none" lIns="0" tIns="0" rIns="0" bIns="0" anchor="b"/>
-          <a:lstStyle/>
-          <a:p>
-            <a:pPr>
-              <a:lnSpc>
-                <a:spcPct val="90000"/>
-              </a:lnSpc>
-              <a:spcBef>
-                <a:spcPts val="0"/>
-              </a:spcBef>
-              <a:spcAft>
-                <a:spcPts val="0"/>
-              </a:spcAft>
-            </a:pPr>
-            <a:r>
-              <a:rPr lang="zh-CN" sz="1200" b="1" dirty="0">
-                <a:solidFill>
-                  <a:srgbClr val="212529"/>
-                </a:solidFill>
-                <a:latin typeface="Noto Sans SC"/>
-                <a:ea typeface="Noto Sans SC"/>
-              </a:rPr>
-              <a:t>lag + 时钟项</a:t>
-            </a:r>
-            <a:endParaRPr lang="zh-CN" sz="1200" b="1" dirty="0">
-              <a:solidFill>
-                <a:srgbClr val="212529"/>
-              </a:solidFill>
-              <a:latin typeface="Noto Sans SC"/>
-              <a:ea typeface="Noto Sans SC"/>
-            </a:endParaRPr>
-          </a:p>
-        </p:txBody>
-      </p:sp>
-      <p:sp>
-        <p:nvSpPr>
-          <p:cNvPr id="640" name="T640"/>
-          <p:cNvSpPr txBox="1"/>
-          <p:nvPr/>
-        </p:nvSpPr>
-        <p:spPr>
-          <a:xfrm>
-            <a:off x="6172200" y="5806678"/>
-            <a:ext cx="457646" cy="228600"/>
-          </a:xfrm>
-          <a:prstGeom prst="rect">
-            <a:avLst/>
-          </a:prstGeom>
-          <a:noFill/>
-          <a:ln>
-            <a:noFill/>
-          </a:ln>
-        </p:spPr>
-        <p:txBody>
-          <a:bodyPr wrap="none" lIns="0" tIns="0" rIns="0" bIns="0" anchor="b"/>
-          <a:lstStyle/>
-          <a:p>
-            <a:pPr>
-              <a:lnSpc>
-                <a:spcPct val="90000"/>
-              </a:lnSpc>
-              <a:spcBef>
-                <a:spcPts val="0"/>
-              </a:spcBef>
-              <a:spcAft>
-                <a:spcPts val="0"/>
-              </a:spcAft>
-            </a:pPr>
-            <a:r>
-              <a:rPr lang="zh-CN" sz="1200" b="1" dirty="0">
-                <a:solidFill>
-                  <a:srgbClr val="212529"/>
-                </a:solidFill>
-                <a:latin typeface="Noto Sans SC"/>
-                <a:ea typeface="Noto Sans SC"/>
-              </a:rPr>
-              <a:t>+ HDD</a:t>
-            </a:r>
-            <a:endParaRPr lang="zh-CN" sz="1200" b="1" dirty="0">
-              <a:solidFill>
-                <a:srgbClr val="212529"/>
-              </a:solidFill>
-              <a:latin typeface="Noto Sans SC"/>
-              <a:ea typeface="Noto Sans SC"/>
-            </a:endParaRPr>
-          </a:p>
-        </p:txBody>
-      </p:sp>
-      <p:sp>
-        <p:nvSpPr>
-          <p:cNvPr id="641" name="T641"/>
-          <p:cNvSpPr txBox="1"/>
-          <p:nvPr/>
-        </p:nvSpPr>
-        <p:spPr>
-          <a:xfrm>
-            <a:off x="6629846" y="5806678"/>
-            <a:ext cx="1896963" cy="228600"/>
-          </a:xfrm>
-          <a:prstGeom prst="rect">
-            <a:avLst/>
-          </a:prstGeom>
-          <a:noFill/>
-          <a:ln>
-            <a:noFill/>
-          </a:ln>
-        </p:spPr>
-        <p:txBody>
-          <a:bodyPr wrap="none" lIns="0" tIns="0" rIns="0" bIns="0" anchor="b"/>
-          <a:lstStyle/>
-          <a:p>
-            <a:pPr>
-              <a:lnSpc>
-                <a:spcPct val="90000"/>
-              </a:lnSpc>
-              <a:spcBef>
-                <a:spcPts val="0"/>
-              </a:spcBef>
-              <a:spcAft>
-                <a:spcPts val="0"/>
-              </a:spcAft>
-            </a:pPr>
-            <a:r>
-              <a:rPr lang="zh-CN" sz="1200" dirty="0">
-                <a:solidFill>
-                  <a:srgbClr val="6B7280"/>
-                </a:solidFill>
-                <a:latin typeface="Noto Sans SC"/>
-                <a:ea typeface="Noto Sans SC"/>
-              </a:rPr>
-              <a:t>为主；光伏子式已显式包含</a:t>
-            </a:r>
-            <a:endParaRPr lang="zh-CN" sz="1200" dirty="0">
-              <a:solidFill>
-                <a:srgbClr val="6B7280"/>
-              </a:solidFill>
-              <a:latin typeface="Noto Sans SC"/>
-              <a:ea typeface="Noto Sans SC"/>
-            </a:endParaRPr>
-          </a:p>
-        </p:txBody>
-      </p:sp>
-      <p:sp>
-        <p:nvSpPr>
-          <p:cNvPr id="642" name="T642"/>
-          <p:cNvSpPr txBox="1"/>
-          <p:nvPr/>
-        </p:nvSpPr>
-        <p:spPr>
-          <a:xfrm>
-            <a:off x="8526809" y="5806678"/>
-            <a:ext cx="2422177" cy="228600"/>
-          </a:xfrm>
-          <a:prstGeom prst="rect">
-            <a:avLst/>
-          </a:prstGeom>
-          <a:noFill/>
-          <a:ln>
-            <a:noFill/>
-          </a:ln>
-        </p:spPr>
-        <p:txBody>
-          <a:bodyPr wrap="none" lIns="0" tIns="0" rIns="0" bIns="0" anchor="b"/>
-          <a:lstStyle/>
-          <a:p>
-            <a:pPr>
-              <a:lnSpc>
-                <a:spcPct val="90000"/>
-              </a:lnSpc>
-              <a:spcBef>
-                <a:spcPts val="0"/>
-              </a:spcBef>
-              <a:spcAft>
-                <a:spcPts val="0"/>
-              </a:spcAft>
-            </a:pPr>
-            <a:r>
-              <a:rPr lang="zh-CN" sz="1200" b="1" dirty="0">
-                <a:solidFill>
-                  <a:srgbClr val="212529"/>
-                </a:solidFill>
-                <a:latin typeface="Noto Sans SC"/>
-                <a:ea typeface="Noto Sans SC"/>
-              </a:rPr>
-              <a:t>GHI / GHI温度修正 / solar altitude</a:t>
-            </a:r>
-            <a:endParaRPr lang="zh-CN" sz="1200" b="1" dirty="0">
-              <a:solidFill>
-                <a:srgbClr val="212529"/>
-              </a:solidFill>
-              <a:latin typeface="Noto Sans SC"/>
-              <a:ea typeface="Noto Sans SC"/>
-            </a:endParaRPr>
-          </a:p>
-        </p:txBody>
-      </p:sp>
-      <p:sp>
-        <p:nvSpPr>
-          <p:cNvPr id="643" name="T643"/>
-          <p:cNvSpPr txBox="1"/>
-          <p:nvPr/>
-        </p:nvSpPr>
-        <p:spPr>
-          <a:xfrm>
-            <a:off x="10948987" y="5806678"/>
-            <a:ext cx="457200" cy="228600"/>
-          </a:xfrm>
-          <a:prstGeom prst="rect">
-            <a:avLst/>
-          </a:prstGeom>
-          <a:noFill/>
-          <a:ln>
-            <a:noFill/>
-          </a:ln>
-        </p:spPr>
-        <p:txBody>
-          <a:bodyPr wrap="none" lIns="0" tIns="0" rIns="0" bIns="0" anchor="b"/>
-          <a:lstStyle/>
-          <a:p>
-            <a:pPr>
-              <a:lnSpc>
-                <a:spcPct val="90000"/>
-              </a:lnSpc>
-              <a:spcBef>
-                <a:spcPts val="0"/>
-              </a:spcBef>
-              <a:spcAft>
-                <a:spcPts val="0"/>
-              </a:spcAft>
-            </a:pPr>
-            <a:r>
-              <a:rPr lang="zh-CN" sz="1200" dirty="0">
-                <a:solidFill>
-                  <a:srgbClr val="6B7280"/>
-                </a:solidFill>
-                <a:latin typeface="Noto Sans SC"/>
-                <a:ea typeface="Noto Sans SC"/>
-              </a:rPr>
-              <a:t>；风侧</a:t>
-            </a:r>
-            <a:endParaRPr lang="zh-CN" sz="1200" dirty="0">
-              <a:solidFill>
-                <a:srgbClr val="6B7280"/>
-              </a:solidFill>
-              <a:latin typeface="Noto Sans SC"/>
-              <a:ea typeface="Noto Sans SC"/>
-            </a:endParaRPr>
-          </a:p>
-        </p:txBody>
-      </p:sp>
-      <p:sp>
-        <p:nvSpPr>
-          <p:cNvPr id="644" name="T644"/>
-          <p:cNvSpPr txBox="1"/>
-          <p:nvPr/>
-        </p:nvSpPr>
-        <p:spPr>
-          <a:xfrm>
-            <a:off x="6172200" y="6027539"/>
-            <a:ext cx="1253281" cy="228600"/>
-          </a:xfrm>
-          <a:prstGeom prst="rect">
-            <a:avLst/>
-          </a:prstGeom>
-          <a:noFill/>
-          <a:ln>
-            <a:noFill/>
-          </a:ln>
-        </p:spPr>
-        <p:txBody>
-          <a:bodyPr wrap="none" lIns="0" tIns="0" rIns="0" bIns="0" anchor="b"/>
-          <a:lstStyle/>
-          <a:p>
-            <a:pPr>
-              <a:lnSpc>
-                <a:spcPct val="90000"/>
-              </a:lnSpc>
-              <a:spcBef>
-                <a:spcPts val="0"/>
-              </a:spcBef>
-              <a:spcAft>
-                <a:spcPts val="0"/>
-              </a:spcAft>
-            </a:pPr>
-            <a:r>
-              <a:rPr lang="zh-CN" sz="1200" dirty="0">
-                <a:solidFill>
-                  <a:srgbClr val="6B7280"/>
-                </a:solidFill>
-                <a:latin typeface="Noto Sans SC"/>
-                <a:ea typeface="Noto Sans SC"/>
-              </a:rPr>
-              <a:t>已有长式，但仍以</a:t>
-            </a:r>
-            <a:endParaRPr lang="zh-CN" sz="1200" dirty="0">
-              <a:solidFill>
-                <a:srgbClr val="6B7280"/>
-              </a:solidFill>
-              <a:latin typeface="Noto Sans SC"/>
-              <a:ea typeface="Noto Sans SC"/>
-            </a:endParaRPr>
-          </a:p>
-        </p:txBody>
-      </p:sp>
-      <p:sp>
-        <p:nvSpPr>
-          <p:cNvPr id="645" name="T645"/>
-          <p:cNvSpPr txBox="1"/>
-          <p:nvPr/>
-        </p:nvSpPr>
-        <p:spPr>
-          <a:xfrm>
-            <a:off x="7544435" y="6093460"/>
-            <a:ext cx="849630" cy="164465"/>
-          </a:xfrm>
-          <a:prstGeom prst="rect">
-            <a:avLst/>
-          </a:prstGeom>
-          <a:noFill/>
-          <a:ln>
-            <a:noFill/>
-          </a:ln>
-        </p:spPr>
-        <p:txBody>
-          <a:bodyPr wrap="none" lIns="0" tIns="0" rIns="0" bIns="0" anchor="b"/>
-          <a:lstStyle/>
-          <a:p>
-            <a:pPr>
-              <a:lnSpc>
-                <a:spcPct val="90000"/>
-              </a:lnSpc>
-              <a:spcBef>
-                <a:spcPts val="0"/>
-              </a:spcBef>
-              <a:spcAft>
-                <a:spcPts val="0"/>
-              </a:spcAft>
-            </a:pPr>
-            <a:r>
-              <a:rPr lang="zh-CN" sz="1200" b="1" dirty="0">
-                <a:solidFill>
-                  <a:srgbClr val="212529"/>
-                </a:solidFill>
-                <a:latin typeface="Noto Sans SC"/>
-                <a:ea typeface="Noto Sans SC"/>
-              </a:rPr>
-              <a:t>wind_lag_12/24/48</a:t>
-            </a:r>
-            <a:endParaRPr lang="zh-CN" sz="1200" b="1" dirty="0">
-              <a:solidFill>
-                <a:srgbClr val="212529"/>
-              </a:solidFill>
-              <a:latin typeface="Noto Sans SC"/>
-              <a:ea typeface="Noto Sans SC"/>
-            </a:endParaRPr>
-          </a:p>
-        </p:txBody>
-      </p:sp>
-      <p:sp>
-        <p:nvSpPr>
-          <p:cNvPr id="646" name="T646"/>
-          <p:cNvSpPr txBox="1"/>
-          <p:nvPr/>
-        </p:nvSpPr>
-        <p:spPr>
-          <a:xfrm>
-            <a:off x="9141608" y="6027539"/>
-            <a:ext cx="2472481" cy="228600"/>
-          </a:xfrm>
-          <a:prstGeom prst="rect">
-            <a:avLst/>
-          </a:prstGeom>
-          <a:noFill/>
-          <a:ln>
-            <a:noFill/>
-          </a:ln>
-        </p:spPr>
-        <p:txBody>
-          <a:bodyPr wrap="none" lIns="0" tIns="0" rIns="0" bIns="0" anchor="b"/>
-          <a:lstStyle/>
-          <a:p>
-            <a:pPr>
-              <a:lnSpc>
-                <a:spcPct val="90000"/>
-              </a:lnSpc>
-              <a:spcBef>
-                <a:spcPts val="0"/>
-              </a:spcBef>
-              <a:spcAft>
-                <a:spcPts val="0"/>
-              </a:spcAft>
-            </a:pPr>
-            <a:r>
-              <a:rPr lang="zh-CN" sz="1200" dirty="0">
-                <a:solidFill>
-                  <a:srgbClr val="6B7280"/>
-                </a:solidFill>
-                <a:latin typeface="Noto Sans SC"/>
-                <a:ea typeface="Noto Sans SC"/>
-              </a:rPr>
-              <a:t>为主，说明替代偏置尚未完全消失。</a:t>
-            </a:r>
-            <a:endParaRPr lang="zh-CN" sz="1200" dirty="0">
-              <a:solidFill>
-                <a:srgbClr val="6B7280"/>
-              </a:solidFill>
-              <a:latin typeface="Noto Sans SC"/>
-              <a:ea typeface="Noto Sans SC"/>
-            </a:endParaRPr>
-          </a:p>
-        </p:txBody>
-      </p:sp>
-      <p:sp>
-        <p:nvSpPr>
           <p:cNvPr id="647" name="T647"/>
           <p:cNvSpPr txBox="1"/>
           <p:nvPr/>
@@ -7129,6 +6589,492 @@
                 <a:ea typeface="Noto Sans SC"/>
               </a:rPr>
               <a:t>(ghi)</a:t>
+            </a:r>
+            <a:endParaRPr lang="zh-CN" sz="1200" dirty="0">
+              <a:solidFill>
+                <a:srgbClr val="6B7280"/>
+              </a:solidFill>
+              <a:latin typeface="Noto Sans SC"/>
+              <a:ea typeface="Noto Sans SC"/>
+            </a:endParaRPr>
+          </a:p>
+        </p:txBody>
+      </p:sp>
+      <p:sp>
+        <p:nvSpPr>
+          <p:cNvPr id="2" name="T650"/>
+          <p:cNvSpPr txBox="1"/>
+          <p:nvPr/>
+        </p:nvSpPr>
+        <p:spPr>
+          <a:xfrm>
+            <a:off x="6238240" y="5465802"/>
+            <a:ext cx="3310681" cy="228600"/>
+          </a:xfrm>
+          <a:prstGeom prst="rect">
+            <a:avLst/>
+          </a:prstGeom>
+          <a:noFill/>
+          <a:ln>
+            <a:noFill/>
+          </a:ln>
+        </p:spPr>
+        <p:txBody>
+          <a:bodyPr wrap="none" lIns="0" tIns="0" rIns="0" bIns="0" anchor="b"/>
+          <a:lstStyle/>
+          <a:p>
+            <a:pPr>
+              <a:lnSpc>
+                <a:spcPct val="90000"/>
+              </a:lnSpc>
+              <a:spcBef>
+                <a:spcPts val="0"/>
+              </a:spcBef>
+              <a:spcAft>
+                <a:spcPts val="0"/>
+              </a:spcAft>
+            </a:pPr>
+            <a:r>
+              <a:rPr lang="zh-CN" sz="1200" dirty="0">
+                <a:solidFill>
+                  <a:srgbClr val="6B7280"/>
+                </a:solidFill>
+                <a:latin typeface="Noto Sans SC"/>
+                <a:ea typeface="Noto Sans SC"/>
+              </a:rPr>
+              <a:t>三条子公式已生成（过长不贴图）。负荷子式包含</a:t>
+            </a:r>
+            <a:endParaRPr lang="zh-CN" sz="1200" dirty="0">
+              <a:solidFill>
+                <a:srgbClr val="6B7280"/>
+              </a:solidFill>
+              <a:latin typeface="Noto Sans SC"/>
+              <a:ea typeface="Noto Sans SC"/>
+            </a:endParaRPr>
+          </a:p>
+        </p:txBody>
+      </p:sp>
+      <p:sp>
+        <p:nvSpPr>
+          <p:cNvPr id="3" name="T651"/>
+          <p:cNvSpPr txBox="1"/>
+          <p:nvPr/>
+        </p:nvSpPr>
+        <p:spPr>
+          <a:xfrm>
+            <a:off x="9636551" y="5465802"/>
+            <a:ext cx="640407" cy="228600"/>
+          </a:xfrm>
+          <a:prstGeom prst="rect">
+            <a:avLst/>
+          </a:prstGeom>
+          <a:noFill/>
+          <a:ln>
+            <a:noFill/>
+          </a:ln>
+        </p:spPr>
+        <p:txBody>
+          <a:bodyPr wrap="none" lIns="0" tIns="0" rIns="0" bIns="0" anchor="b"/>
+          <a:lstStyle/>
+          <a:p>
+            <a:pPr>
+              <a:lnSpc>
+                <a:spcPct val="90000"/>
+              </a:lnSpc>
+              <a:spcBef>
+                <a:spcPts val="0"/>
+              </a:spcBef>
+              <a:spcAft>
+                <a:spcPts val="0"/>
+              </a:spcAft>
+            </a:pPr>
+            <a:r>
+              <a:rPr lang="zh-CN" sz="1200" b="1" dirty="0">
+                <a:solidFill>
+                  <a:srgbClr val="212529"/>
+                </a:solidFill>
+                <a:latin typeface="Noto Sans SC"/>
+                <a:ea typeface="Noto Sans SC"/>
+              </a:rPr>
+              <a:t>hdd_18c</a:t>
+            </a:r>
+            <a:endParaRPr lang="zh-CN" sz="1200" b="1" dirty="0">
+              <a:solidFill>
+                <a:srgbClr val="212529"/>
+              </a:solidFill>
+              <a:latin typeface="Noto Sans SC"/>
+              <a:ea typeface="Noto Sans SC"/>
+            </a:endParaRPr>
+          </a:p>
+        </p:txBody>
+      </p:sp>
+      <p:sp>
+        <p:nvSpPr>
+          <p:cNvPr id="652" name="T652"/>
+          <p:cNvSpPr txBox="1"/>
+          <p:nvPr/>
+        </p:nvSpPr>
+        <p:spPr>
+          <a:xfrm>
+            <a:off x="10189329" y="5465802"/>
+            <a:ext cx="1371600" cy="228600"/>
+          </a:xfrm>
+          <a:prstGeom prst="rect">
+            <a:avLst/>
+          </a:prstGeom>
+          <a:noFill/>
+          <a:ln>
+            <a:noFill/>
+          </a:ln>
+        </p:spPr>
+        <p:txBody>
+          <a:bodyPr wrap="none" lIns="0" tIns="0" rIns="0" bIns="0" anchor="b"/>
+          <a:lstStyle/>
+          <a:p>
+            <a:pPr>
+              <a:lnSpc>
+                <a:spcPct val="90000"/>
+              </a:lnSpc>
+              <a:spcBef>
+                <a:spcPts val="0"/>
+              </a:spcBef>
+              <a:spcAft>
+                <a:spcPts val="0"/>
+              </a:spcAft>
+            </a:pPr>
+            <a:r>
+              <a:rPr lang="zh-CN" sz="1200" dirty="0">
+                <a:solidFill>
+                  <a:srgbClr val="6B7280"/>
+                </a:solidFill>
+                <a:latin typeface="Noto Sans SC"/>
+                <a:ea typeface="Noto Sans SC"/>
+              </a:rPr>
+              <a:t>（温度代理）；光伏</a:t>
+            </a:r>
+            <a:endParaRPr lang="zh-CN" sz="1200" dirty="0">
+              <a:solidFill>
+                <a:srgbClr val="6B7280"/>
+              </a:solidFill>
+              <a:latin typeface="Noto Sans SC"/>
+              <a:ea typeface="Noto Sans SC"/>
+            </a:endParaRPr>
+          </a:p>
+        </p:txBody>
+      </p:sp>
+      <p:sp>
+        <p:nvSpPr>
+          <p:cNvPr id="4" name="T653"/>
+          <p:cNvSpPr txBox="1"/>
+          <p:nvPr/>
+        </p:nvSpPr>
+        <p:spPr>
+          <a:xfrm>
+            <a:off x="6203315" y="5694918"/>
+            <a:ext cx="643681" cy="228600"/>
+          </a:xfrm>
+          <a:prstGeom prst="rect">
+            <a:avLst/>
+          </a:prstGeom>
+          <a:noFill/>
+          <a:ln>
+            <a:noFill/>
+          </a:ln>
+        </p:spPr>
+        <p:txBody>
+          <a:bodyPr wrap="none" lIns="0" tIns="0" rIns="0" bIns="0" anchor="b"/>
+          <a:lstStyle/>
+          <a:p>
+            <a:pPr>
+              <a:lnSpc>
+                <a:spcPct val="90000"/>
+              </a:lnSpc>
+              <a:spcBef>
+                <a:spcPts val="0"/>
+              </a:spcBef>
+              <a:spcAft>
+                <a:spcPts val="0"/>
+              </a:spcAft>
+            </a:pPr>
+            <a:r>
+              <a:rPr lang="zh-CN" sz="1200" dirty="0">
+                <a:solidFill>
+                  <a:srgbClr val="6B7280"/>
+                </a:solidFill>
+                <a:latin typeface="Noto Sans SC"/>
+                <a:ea typeface="Noto Sans SC"/>
+              </a:rPr>
+              <a:t>子式包含</a:t>
+            </a:r>
+            <a:endParaRPr lang="zh-CN" sz="1200" dirty="0">
+              <a:solidFill>
+                <a:srgbClr val="6B7280"/>
+              </a:solidFill>
+              <a:latin typeface="Noto Sans SC"/>
+              <a:ea typeface="Noto Sans SC"/>
+            </a:endParaRPr>
+          </a:p>
+        </p:txBody>
+      </p:sp>
+      <p:sp>
+        <p:nvSpPr>
+          <p:cNvPr id="5" name="T654"/>
+          <p:cNvSpPr txBox="1"/>
+          <p:nvPr/>
+        </p:nvSpPr>
+        <p:spPr>
+          <a:xfrm>
+            <a:off x="6881921" y="5686663"/>
+            <a:ext cx="1993255" cy="228600"/>
+          </a:xfrm>
+          <a:prstGeom prst="rect">
+            <a:avLst/>
+          </a:prstGeom>
+          <a:noFill/>
+          <a:ln>
+            <a:noFill/>
+          </a:ln>
+        </p:spPr>
+        <p:txBody>
+          <a:bodyPr wrap="none" lIns="0" tIns="0" rIns="0" bIns="0" anchor="b"/>
+          <a:lstStyle/>
+          <a:p>
+            <a:pPr>
+              <a:lnSpc>
+                <a:spcPct val="90000"/>
+              </a:lnSpc>
+              <a:spcBef>
+                <a:spcPts val="0"/>
+              </a:spcBef>
+              <a:spcAft>
+                <a:spcPts val="0"/>
+              </a:spcAft>
+            </a:pPr>
+            <a:r>
+              <a:rPr lang="zh-CN" sz="1200" b="1" dirty="0">
+                <a:solidFill>
+                  <a:srgbClr val="212529"/>
+                </a:solidFill>
+                <a:latin typeface="Noto Sans SC"/>
+                <a:ea typeface="Noto Sans SC"/>
+              </a:rPr>
+              <a:t>ghi_w_m2 + solar_altitude</a:t>
+            </a:r>
+            <a:endParaRPr lang="zh-CN" sz="1200" b="1" dirty="0">
+              <a:solidFill>
+                <a:srgbClr val="212529"/>
+              </a:solidFill>
+              <a:latin typeface="Noto Sans SC"/>
+              <a:ea typeface="Noto Sans SC"/>
+            </a:endParaRPr>
+          </a:p>
+        </p:txBody>
+      </p:sp>
+      <p:sp>
+        <p:nvSpPr>
+          <p:cNvPr id="6" name="T655"/>
+          <p:cNvSpPr txBox="1"/>
+          <p:nvPr/>
+        </p:nvSpPr>
+        <p:spPr>
+          <a:xfrm>
+            <a:off x="8875176" y="5686663"/>
+            <a:ext cx="1100881" cy="228600"/>
+          </a:xfrm>
+          <a:prstGeom prst="rect">
+            <a:avLst/>
+          </a:prstGeom>
+          <a:noFill/>
+          <a:ln>
+            <a:noFill/>
+          </a:ln>
+        </p:spPr>
+        <p:txBody>
+          <a:bodyPr wrap="none" lIns="0" tIns="0" rIns="0" bIns="0" anchor="b"/>
+          <a:lstStyle/>
+          <a:p>
+            <a:pPr>
+              <a:lnSpc>
+                <a:spcPct val="90000"/>
+              </a:lnSpc>
+              <a:spcBef>
+                <a:spcPts val="0"/>
+              </a:spcBef>
+              <a:spcAft>
+                <a:spcPts val="0"/>
+              </a:spcAft>
+            </a:pPr>
+            <a:r>
+              <a:rPr lang="zh-CN" sz="1200" dirty="0">
+                <a:solidFill>
+                  <a:srgbClr val="6B7280"/>
+                </a:solidFill>
+                <a:latin typeface="Noto Sans SC"/>
+                <a:ea typeface="Noto Sans SC"/>
+              </a:rPr>
+              <a:t>；风电子式包含</a:t>
+            </a:r>
+            <a:endParaRPr lang="zh-CN" sz="1200" dirty="0">
+              <a:solidFill>
+                <a:srgbClr val="6B7280"/>
+              </a:solidFill>
+              <a:latin typeface="Noto Sans SC"/>
+              <a:ea typeface="Noto Sans SC"/>
+            </a:endParaRPr>
+          </a:p>
+        </p:txBody>
+      </p:sp>
+      <p:sp>
+        <p:nvSpPr>
+          <p:cNvPr id="7" name="T656"/>
+          <p:cNvSpPr txBox="1"/>
+          <p:nvPr/>
+        </p:nvSpPr>
+        <p:spPr>
+          <a:xfrm>
+            <a:off x="9976058" y="5686663"/>
+            <a:ext cx="1553170" cy="228600"/>
+          </a:xfrm>
+          <a:prstGeom prst="rect">
+            <a:avLst/>
+          </a:prstGeom>
+          <a:noFill/>
+          <a:ln>
+            <a:noFill/>
+          </a:ln>
+        </p:spPr>
+        <p:txBody>
+          <a:bodyPr wrap="none" lIns="0" tIns="0" rIns="0" bIns="0" anchor="b"/>
+          <a:lstStyle/>
+          <a:p>
+            <a:pPr>
+              <a:lnSpc>
+                <a:spcPct val="90000"/>
+              </a:lnSpc>
+              <a:spcBef>
+                <a:spcPts val="0"/>
+              </a:spcBef>
+              <a:spcAft>
+                <a:spcPts val="0"/>
+              </a:spcAft>
+            </a:pPr>
+            <a:r>
+              <a:rPr lang="zh-CN" sz="1200" b="1" dirty="0">
+                <a:solidFill>
+                  <a:srgbClr val="212529"/>
+                </a:solidFill>
+                <a:latin typeface="Noto Sans SC"/>
+                <a:ea typeface="Noto Sans SC"/>
+              </a:rPr>
+              <a:t>wind_speed 及其物理</a:t>
+            </a:r>
+            <a:endParaRPr lang="zh-CN" sz="1200" b="1" dirty="0">
+              <a:solidFill>
+                <a:srgbClr val="212529"/>
+              </a:solidFill>
+              <a:latin typeface="Noto Sans SC"/>
+              <a:ea typeface="Noto Sans SC"/>
+            </a:endParaRPr>
+          </a:p>
+        </p:txBody>
+      </p:sp>
+      <p:sp>
+        <p:nvSpPr>
+          <p:cNvPr id="8" name="T657"/>
+          <p:cNvSpPr txBox="1"/>
+          <p:nvPr/>
+        </p:nvSpPr>
+        <p:spPr>
+          <a:xfrm>
+            <a:off x="6238240" y="5907524"/>
+            <a:ext cx="304800" cy="228600"/>
+          </a:xfrm>
+          <a:prstGeom prst="rect">
+            <a:avLst/>
+          </a:prstGeom>
+          <a:noFill/>
+          <a:ln>
+            <a:noFill/>
+          </a:ln>
+        </p:spPr>
+        <p:txBody>
+          <a:bodyPr wrap="none" lIns="0" tIns="0" rIns="0" bIns="0" anchor="b"/>
+          <a:lstStyle/>
+          <a:p>
+            <a:pPr>
+              <a:lnSpc>
+                <a:spcPct val="90000"/>
+              </a:lnSpc>
+              <a:spcBef>
+                <a:spcPts val="0"/>
+              </a:spcBef>
+              <a:spcAft>
+                <a:spcPts val="0"/>
+              </a:spcAft>
+            </a:pPr>
+            <a:r>
+              <a:rPr lang="zh-CN" sz="1200" b="1" dirty="0">
+                <a:solidFill>
+                  <a:srgbClr val="212529"/>
+                </a:solidFill>
+                <a:latin typeface="Noto Sans SC"/>
+                <a:ea typeface="Noto Sans SC"/>
+              </a:rPr>
+              <a:t>变换</a:t>
+            </a:r>
+            <a:endParaRPr lang="zh-CN" sz="1200" b="1" dirty="0">
+              <a:solidFill>
+                <a:srgbClr val="212529"/>
+              </a:solidFill>
+              <a:latin typeface="Noto Sans SC"/>
+              <a:ea typeface="Noto Sans SC"/>
+            </a:endParaRPr>
+          </a:p>
+        </p:txBody>
+      </p:sp>
+      <p:sp>
+        <p:nvSpPr>
+          <p:cNvPr id="9" name="T658"/>
+          <p:cNvSpPr txBox="1"/>
+          <p:nvPr/>
+        </p:nvSpPr>
+        <p:spPr>
+          <a:xfrm>
+            <a:off x="6543040" y="5907524"/>
+            <a:ext cx="3493442" cy="228600"/>
+          </a:xfrm>
+          <a:prstGeom prst="rect">
+            <a:avLst/>
+          </a:prstGeom>
+          <a:noFill/>
+          <a:ln>
+            <a:noFill/>
+          </a:ln>
+        </p:spPr>
+        <p:txBody>
+          <a:bodyPr wrap="none" lIns="0" tIns="0" rIns="0" bIns="0" anchor="b"/>
+          <a:lstStyle/>
+          <a:p>
+            <a:pPr>
+              <a:lnSpc>
+                <a:spcPct val="90000"/>
+              </a:lnSpc>
+              <a:spcBef>
+                <a:spcPts val="0"/>
+              </a:spcBef>
+              <a:spcAft>
+                <a:spcPts val="0"/>
+              </a:spcAft>
+            </a:pPr>
+            <a:r>
+              <a:rPr lang="zh-CN" sz="1200" dirty="0">
+                <a:solidFill>
+                  <a:srgbClr val="6B7280"/>
+                </a:solidFill>
+                <a:latin typeface="Noto Sans SC"/>
+                <a:ea typeface="Noto Sans SC"/>
+              </a:rPr>
+              <a:t>。三者目标物理量 FAR 均为 3/3，与物理预期一致。</a:t>
             </a:r>
             <a:endParaRPr lang="zh-CN" sz="1200" dirty="0">
               <a:solidFill>
@@ -15312,8 +15258,8 @@
         </p:nvSpPr>
         <p:spPr>
           <a:xfrm>
-            <a:off x="371475" y="771525"/>
-            <a:ext cx="28575" cy="3714750"/>
+            <a:off x="323850" y="771525"/>
+            <a:ext cx="76200" cy="3099435"/>
           </a:xfrm>
           <a:prstGeom prst="roundRect">
             <a:avLst>
@@ -21065,7 +21011,7 @@
         <p:spPr>
           <a:xfrm>
             <a:off x="733425" y="2638425"/>
-            <a:ext cx="1765101" cy="323850"/>
+            <a:ext cx="1818640" cy="323850"/>
           </a:xfrm>
           <a:prstGeom prst="roundRect">
             <a:avLst>
@@ -25557,6 +25503,12 @@
             </a:solidFill>
           </a:ln>
         </p:spPr>
+        <p:txBody>
+          <a:bodyPr/>
+          <a:p>
+            <a:endParaRPr lang="zh-CN" altLang="en-US"/>
+          </a:p>
+        </p:txBody>
       </p:sp>
       <p:sp>
         <p:nvSpPr>
@@ -25803,7 +25755,7 @@
         </p:nvSpPr>
         <p:spPr>
           <a:xfrm>
-            <a:off x="6410325" y="3548955"/>
+            <a:off x="6866255" y="3548955"/>
             <a:ext cx="1432321" cy="257175"/>
           </a:xfrm>
           <a:prstGeom prst="rect">
@@ -26012,7 +25964,7 @@
         </p:nvSpPr>
         <p:spPr>
           <a:xfrm>
-            <a:off x="6467475" y="4939605"/>
+            <a:off x="6810375" y="4939605"/>
             <a:ext cx="342900" cy="257175"/>
           </a:xfrm>
           <a:prstGeom prst="rect">
@@ -26066,7 +26018,7 @@
         </p:nvSpPr>
         <p:spPr>
           <a:xfrm>
-            <a:off x="6553200" y="5177730"/>
+            <a:off x="6896100" y="5177730"/>
             <a:ext cx="171450" cy="257175"/>
           </a:xfrm>
           <a:prstGeom prst="rect">
@@ -26120,7 +26072,7 @@
         </p:nvSpPr>
         <p:spPr>
           <a:xfrm>
-            <a:off x="7000875" y="4939605"/>
+            <a:off x="8041640" y="4939605"/>
             <a:ext cx="342900" cy="257175"/>
           </a:xfrm>
           <a:prstGeom prst="rect">
@@ -26174,7 +26126,7 @@
         </p:nvSpPr>
         <p:spPr>
           <a:xfrm>
-            <a:off x="7086600" y="5177730"/>
+            <a:off x="8127365" y="5177730"/>
             <a:ext cx="171450" cy="257175"/>
           </a:xfrm>
           <a:prstGeom prst="rect">
@@ -26359,7 +26311,7 @@
         </p:nvSpPr>
         <p:spPr>
           <a:xfrm>
-            <a:off x="9010650" y="3548955"/>
+            <a:off x="9356090" y="3499425"/>
             <a:ext cx="1607194" cy="257175"/>
           </a:xfrm>
           <a:prstGeom prst="rect">
@@ -26568,7 +26520,7 @@
         </p:nvSpPr>
         <p:spPr>
           <a:xfrm>
-            <a:off x="9067800" y="4939605"/>
+            <a:off x="9410700" y="4939605"/>
             <a:ext cx="342900" cy="257175"/>
           </a:xfrm>
           <a:prstGeom prst="rect">
@@ -26622,7 +26574,7 @@
         </p:nvSpPr>
         <p:spPr>
           <a:xfrm>
-            <a:off x="9153525" y="5177730"/>
+            <a:off x="9496425" y="5177730"/>
             <a:ext cx="171450" cy="257175"/>
           </a:xfrm>
           <a:prstGeom prst="rect">
@@ -26676,7 +26628,7 @@
         </p:nvSpPr>
         <p:spPr>
           <a:xfrm>
-            <a:off x="9601200" y="4939605"/>
+            <a:off x="10632440" y="5015805"/>
             <a:ext cx="342900" cy="257175"/>
           </a:xfrm>
           <a:prstGeom prst="rect">
@@ -26730,7 +26682,7 @@
         </p:nvSpPr>
         <p:spPr>
           <a:xfrm>
-            <a:off x="9686925" y="5177730"/>
+            <a:off x="10718165" y="5253930"/>
             <a:ext cx="171450" cy="257175"/>
           </a:xfrm>
           <a:prstGeom prst="rect">
@@ -26928,114 +26880,6 @@
             </a:solidFill>
           </a:ln>
         </p:spPr>
-      </p:sp>
-      <p:sp>
-        <p:nvSpPr>
-          <p:cNvPr id="511" name="T511"/>
-          <p:cNvSpPr txBox="1"/>
-          <p:nvPr/>
-        </p:nvSpPr>
-        <p:spPr>
-          <a:xfrm>
-            <a:off x="6410325" y="6360616"/>
-            <a:ext cx="706487" cy="257175"/>
-          </a:xfrm>
-          <a:prstGeom prst="rect">
-            <a:avLst/>
-          </a:prstGeom>
-          <a:noFill/>
-          <a:ln>
-            <a:noFill/>
-          </a:ln>
-        </p:spPr>
-        <p:txBody>
-          <a:bodyPr wrap="none" lIns="0" tIns="0" rIns="0" bIns="0" anchor="b"/>
-          <a:lstStyle/>
-          <a:p>
-            <a:pPr>
-              <a:lnSpc>
-                <a:spcPct val="90000"/>
-              </a:lnSpc>
-              <a:spcBef>
-                <a:spcPts val="0"/>
-              </a:spcBef>
-              <a:spcAft>
-                <a:spcPts val="0"/>
-              </a:spcAft>
-            </a:pPr>
-            <a:r>
-              <a:rPr lang="zh-CN" sz="1350" dirty="0">
-                <a:solidFill>
-                  <a:srgbClr val="6B7280"/>
-                </a:solidFill>
-                <a:latin typeface="Noto Sans SC"/>
-                <a:ea typeface="Noto Sans SC"/>
-              </a:rPr>
-              <a:t>微观反转</a:t>
-            </a:r>
-            <a:endParaRPr lang="zh-CN" sz="1350" dirty="0">
-              <a:solidFill>
-                <a:srgbClr val="6B7280"/>
-              </a:solidFill>
-              <a:latin typeface="Noto Sans SC"/>
-              <a:ea typeface="Noto Sans SC"/>
-            </a:endParaRPr>
-          </a:p>
-        </p:txBody>
-      </p:sp>
-      <p:sp>
-        <p:nvSpPr>
-          <p:cNvPr id="512" name="T512"/>
-          <p:cNvSpPr txBox="1"/>
-          <p:nvPr/>
-        </p:nvSpPr>
-        <p:spPr>
-          <a:xfrm>
-            <a:off x="6410325" y="6598741"/>
-            <a:ext cx="453776" cy="257175"/>
-          </a:xfrm>
-          <a:prstGeom prst="rect">
-            <a:avLst/>
-          </a:prstGeom>
-          <a:noFill/>
-          <a:ln>
-            <a:noFill/>
-          </a:ln>
-        </p:spPr>
-        <p:txBody>
-          <a:bodyPr wrap="none" lIns="0" tIns="0" rIns="0" bIns="0" anchor="b"/>
-          <a:lstStyle/>
-          <a:p>
-            <a:pPr>
-              <a:lnSpc>
-                <a:spcPct val="90000"/>
-              </a:lnSpc>
-              <a:spcBef>
-                <a:spcPts val="0"/>
-              </a:spcBef>
-              <a:spcAft>
-                <a:spcPts val="0"/>
-              </a:spcAft>
-            </a:pPr>
-            <a:r>
-              <a:rPr lang="zh-CN" sz="1350" dirty="0">
-                <a:solidFill>
-                  <a:srgbClr val="6B7280"/>
-                </a:solidFill>
-                <a:latin typeface="Noto Sans SC"/>
-                <a:ea typeface="Noto Sans SC"/>
-              </a:rPr>
-              <a:t>种子1</a:t>
-            </a:r>
-            <a:endParaRPr lang="zh-CN" sz="1350" dirty="0">
-              <a:solidFill>
-                <a:srgbClr val="6B7280"/>
-              </a:solidFill>
-              <a:latin typeface="Noto Sans SC"/>
-              <a:ea typeface="Noto Sans SC"/>
-            </a:endParaRPr>
-          </a:p>
-        </p:txBody>
       </p:sp>
       <p:sp>
         <p:nvSpPr>
@@ -27530,7 +27374,7 @@
         </p:nvSpPr>
         <p:spPr>
           <a:xfrm>
-            <a:off x="542925" y="1533525"/>
+            <a:off x="542925" y="1732915"/>
             <a:ext cx="28575" cy="1524000"/>
           </a:xfrm>
           <a:prstGeom prst="roundRect">
@@ -30879,8 +30723,8 @@
         </p:nvSpPr>
         <p:spPr>
           <a:xfrm>
-            <a:off x="5654873" y="3314700"/>
-            <a:ext cx="5955952" cy="3571577"/>
+            <a:off x="5654675" y="3314700"/>
+            <a:ext cx="5955665" cy="3152140"/>
           </a:xfrm>
           <a:prstGeom prst="roundRect">
             <a:avLst>
@@ -31198,7 +31042,7 @@
         </p:nvSpPr>
         <p:spPr>
           <a:xfrm>
-            <a:off x="6242595" y="4008090"/>
+            <a:off x="6320065" y="4008090"/>
             <a:ext cx="152400" cy="228600"/>
           </a:xfrm>
           <a:prstGeom prst="rect">

</xml_diff>